<commit_message>
added scval + fix warning
</commit_message>
<xml_diff>
--- a/graphics/graphics.pptx
+++ b/graphics/graphics.pptx
@@ -6,7 +6,7 @@
     <p:sldMasterId id="2147483660" r:id="rId2"/>
   </p:sldMasterIdLst>
   <p:notesMasterIdLst>
-    <p:notesMasterId r:id="rId11"/>
+    <p:notesMasterId r:id="rId12"/>
   </p:notesMasterIdLst>
   <p:sldIdLst>
     <p:sldId id="259" r:id="rId3"/>
@@ -17,6 +17,7 @@
     <p:sldId id="263" r:id="rId8"/>
     <p:sldId id="264" r:id="rId9"/>
     <p:sldId id="265" r:id="rId10"/>
+    <p:sldId id="266" r:id="rId11"/>
   </p:sldIdLst>
   <p:sldSz cx="12192000" cy="6858000"/>
   <p:notesSz cx="6858000" cy="9144000"/>
@@ -205,7 +206,7 @@
           <a:p>
             <a:fld id="{B8404A9E-F80D-47A3-9ABE-4E375F8C7A58}" type="datetimeFigureOut">
               <a:rPr lang="fr-CA" smtClean="0"/>
-              <a:t>2026-02-26</a:t>
+              <a:t>2026-03-19</a:t>
             </a:fld>
             <a:endParaRPr lang="fr-CA"/>
           </a:p>
@@ -622,7 +623,7 @@
           <a:p>
             <a:fld id="{B1B97C2F-ED53-40B2-8245-274A53568F1F}" type="datetimeFigureOut">
               <a:rPr lang="fr-CA" smtClean="0"/>
-              <a:t>2026-02-26</a:t>
+              <a:t>2026-03-19</a:t>
             </a:fld>
             <a:endParaRPr lang="fr-CA"/>
           </a:p>
@@ -822,7 +823,7 @@
           <a:p>
             <a:fld id="{B1B97C2F-ED53-40B2-8245-274A53568F1F}" type="datetimeFigureOut">
               <a:rPr lang="fr-CA" smtClean="0"/>
-              <a:t>2026-02-26</a:t>
+              <a:t>2026-03-19</a:t>
             </a:fld>
             <a:endParaRPr lang="fr-CA"/>
           </a:p>
@@ -1032,7 +1033,7 @@
           <a:p>
             <a:fld id="{B1B97C2F-ED53-40B2-8245-274A53568F1F}" type="datetimeFigureOut">
               <a:rPr lang="fr-CA" smtClean="0"/>
-              <a:t>2026-02-26</a:t>
+              <a:t>2026-03-19</a:t>
             </a:fld>
             <a:endParaRPr lang="fr-CA"/>
           </a:p>
@@ -1254,7 +1255,7 @@
           <a:p>
             <a:fld id="{3CFA78C3-2C03-4D26-BA08-5201FB292C09}" type="datetimeFigureOut">
               <a:rPr lang="fr-CA" smtClean="0"/>
-              <a:t>2026-02-26</a:t>
+              <a:t>2026-03-19</a:t>
             </a:fld>
             <a:endParaRPr lang="fr-CA"/>
           </a:p>
@@ -1454,7 +1455,7 @@
           <a:p>
             <a:fld id="{3CFA78C3-2C03-4D26-BA08-5201FB292C09}" type="datetimeFigureOut">
               <a:rPr lang="fr-CA" smtClean="0"/>
-              <a:t>2026-02-26</a:t>
+              <a:t>2026-03-19</a:t>
             </a:fld>
             <a:endParaRPr lang="fr-CA"/>
           </a:p>
@@ -1730,7 +1731,7 @@
           <a:p>
             <a:fld id="{3CFA78C3-2C03-4D26-BA08-5201FB292C09}" type="datetimeFigureOut">
               <a:rPr lang="fr-CA" smtClean="0"/>
-              <a:t>2026-02-26</a:t>
+              <a:t>2026-03-19</a:t>
             </a:fld>
             <a:endParaRPr lang="fr-CA"/>
           </a:p>
@@ -1998,7 +1999,7 @@
           <a:p>
             <a:fld id="{3CFA78C3-2C03-4D26-BA08-5201FB292C09}" type="datetimeFigureOut">
               <a:rPr lang="fr-CA" smtClean="0"/>
-              <a:t>2026-02-26</a:t>
+              <a:t>2026-03-19</a:t>
             </a:fld>
             <a:endParaRPr lang="fr-CA"/>
           </a:p>
@@ -2413,7 +2414,7 @@
           <a:p>
             <a:fld id="{3CFA78C3-2C03-4D26-BA08-5201FB292C09}" type="datetimeFigureOut">
               <a:rPr lang="fr-CA" smtClean="0"/>
-              <a:t>2026-02-26</a:t>
+              <a:t>2026-03-19</a:t>
             </a:fld>
             <a:endParaRPr lang="fr-CA"/>
           </a:p>
@@ -2555,7 +2556,7 @@
           <a:p>
             <a:fld id="{3CFA78C3-2C03-4D26-BA08-5201FB292C09}" type="datetimeFigureOut">
               <a:rPr lang="fr-CA" smtClean="0"/>
-              <a:t>2026-02-26</a:t>
+              <a:t>2026-03-19</a:t>
             </a:fld>
             <a:endParaRPr lang="fr-CA"/>
           </a:p>
@@ -2668,7 +2669,7 @@
           <a:p>
             <a:fld id="{3CFA78C3-2C03-4D26-BA08-5201FB292C09}" type="datetimeFigureOut">
               <a:rPr lang="fr-CA" smtClean="0"/>
-              <a:t>2026-02-26</a:t>
+              <a:t>2026-03-19</a:t>
             </a:fld>
             <a:endParaRPr lang="fr-CA"/>
           </a:p>
@@ -2981,7 +2982,7 @@
           <a:p>
             <a:fld id="{3CFA78C3-2C03-4D26-BA08-5201FB292C09}" type="datetimeFigureOut">
               <a:rPr lang="fr-CA" smtClean="0"/>
-              <a:t>2026-02-26</a:t>
+              <a:t>2026-03-19</a:t>
             </a:fld>
             <a:endParaRPr lang="fr-CA"/>
           </a:p>
@@ -3181,7 +3182,7 @@
           <a:p>
             <a:fld id="{B1B97C2F-ED53-40B2-8245-274A53568F1F}" type="datetimeFigureOut">
               <a:rPr lang="fr-CA" smtClean="0"/>
-              <a:t>2026-02-26</a:t>
+              <a:t>2026-03-19</a:t>
             </a:fld>
             <a:endParaRPr lang="fr-CA"/>
           </a:p>
@@ -3470,7 +3471,7 @@
           <a:p>
             <a:fld id="{3CFA78C3-2C03-4D26-BA08-5201FB292C09}" type="datetimeFigureOut">
               <a:rPr lang="fr-CA" smtClean="0"/>
-              <a:t>2026-02-26</a:t>
+              <a:t>2026-03-19</a:t>
             </a:fld>
             <a:endParaRPr lang="fr-CA"/>
           </a:p>
@@ -3670,7 +3671,7 @@
           <a:p>
             <a:fld id="{3CFA78C3-2C03-4D26-BA08-5201FB292C09}" type="datetimeFigureOut">
               <a:rPr lang="fr-CA" smtClean="0"/>
-              <a:t>2026-02-26</a:t>
+              <a:t>2026-03-19</a:t>
             </a:fld>
             <a:endParaRPr lang="fr-CA"/>
           </a:p>
@@ -3880,7 +3881,7 @@
           <a:p>
             <a:fld id="{3CFA78C3-2C03-4D26-BA08-5201FB292C09}" type="datetimeFigureOut">
               <a:rPr lang="fr-CA" smtClean="0"/>
-              <a:t>2026-02-26</a:t>
+              <a:t>2026-03-19</a:t>
             </a:fld>
             <a:endParaRPr lang="fr-CA"/>
           </a:p>
@@ -4156,7 +4157,7 @@
           <a:p>
             <a:fld id="{B1B97C2F-ED53-40B2-8245-274A53568F1F}" type="datetimeFigureOut">
               <a:rPr lang="fr-CA" smtClean="0"/>
-              <a:t>2026-02-26</a:t>
+              <a:t>2026-03-19</a:t>
             </a:fld>
             <a:endParaRPr lang="fr-CA"/>
           </a:p>
@@ -4424,7 +4425,7 @@
           <a:p>
             <a:fld id="{B1B97C2F-ED53-40B2-8245-274A53568F1F}" type="datetimeFigureOut">
               <a:rPr lang="fr-CA" smtClean="0"/>
-              <a:t>2026-02-26</a:t>
+              <a:t>2026-03-19</a:t>
             </a:fld>
             <a:endParaRPr lang="fr-CA"/>
           </a:p>
@@ -4839,7 +4840,7 @@
           <a:p>
             <a:fld id="{B1B97C2F-ED53-40B2-8245-274A53568F1F}" type="datetimeFigureOut">
               <a:rPr lang="fr-CA" smtClean="0"/>
-              <a:t>2026-02-26</a:t>
+              <a:t>2026-03-19</a:t>
             </a:fld>
             <a:endParaRPr lang="fr-CA"/>
           </a:p>
@@ -4981,7 +4982,7 @@
           <a:p>
             <a:fld id="{B1B97C2F-ED53-40B2-8245-274A53568F1F}" type="datetimeFigureOut">
               <a:rPr lang="fr-CA" smtClean="0"/>
-              <a:t>2026-02-26</a:t>
+              <a:t>2026-03-19</a:t>
             </a:fld>
             <a:endParaRPr lang="fr-CA"/>
           </a:p>
@@ -5094,7 +5095,7 @@
           <a:p>
             <a:fld id="{B1B97C2F-ED53-40B2-8245-274A53568F1F}" type="datetimeFigureOut">
               <a:rPr lang="fr-CA" smtClean="0"/>
-              <a:t>2026-02-26</a:t>
+              <a:t>2026-03-19</a:t>
             </a:fld>
             <a:endParaRPr lang="fr-CA"/>
           </a:p>
@@ -5407,7 +5408,7 @@
           <a:p>
             <a:fld id="{B1B97C2F-ED53-40B2-8245-274A53568F1F}" type="datetimeFigureOut">
               <a:rPr lang="fr-CA" smtClean="0"/>
-              <a:t>2026-02-26</a:t>
+              <a:t>2026-03-19</a:t>
             </a:fld>
             <a:endParaRPr lang="fr-CA"/>
           </a:p>
@@ -5696,7 +5697,7 @@
           <a:p>
             <a:fld id="{B1B97C2F-ED53-40B2-8245-274A53568F1F}" type="datetimeFigureOut">
               <a:rPr lang="fr-CA" smtClean="0"/>
-              <a:t>2026-02-26</a:t>
+              <a:t>2026-03-19</a:t>
             </a:fld>
             <a:endParaRPr lang="fr-CA"/>
           </a:p>
@@ -5939,7 +5940,7 @@
           <a:p>
             <a:fld id="{B1B97C2F-ED53-40B2-8245-274A53568F1F}" type="datetimeFigureOut">
               <a:rPr lang="fr-CA" smtClean="0"/>
-              <a:t>2026-02-26</a:t>
+              <a:t>2026-03-19</a:t>
             </a:fld>
             <a:endParaRPr lang="fr-CA"/>
           </a:p>
@@ -6509,7 +6510,7 @@
           <a:p>
             <a:fld id="{3CFA78C3-2C03-4D26-BA08-5201FB292C09}" type="datetimeFigureOut">
               <a:rPr lang="fr-CA" smtClean="0"/>
-              <a:t>2026-02-26</a:t>
+              <a:t>2026-03-19</a:t>
             </a:fld>
             <a:endParaRPr lang="fr-CA"/>
           </a:p>
@@ -8800,6 +8801,7 @@
           <a:solidFill>
             <a:srgbClr val="E32E36"/>
           </a:solidFill>
+          <a:ln w="25400"/>
         </p:spPr>
         <p:style>
           <a:lnRef idx="2">
@@ -9104,12 +9106,90 @@
           </a:p>
         </p:txBody>
       </p:sp>
+      <p:sp>
+        <p:nvSpPr>
+          <p:cNvPr id="4" name="Ellipse 3">
+            <a:extLst>
+              <a:ext uri="{FF2B5EF4-FFF2-40B4-BE49-F238E27FC236}">
+                <a16:creationId xmlns:a16="http://schemas.microsoft.com/office/drawing/2014/main" id="{4681F7E5-A3DB-1479-3EEA-0D1191E58396}"/>
+              </a:ext>
+            </a:extLst>
+          </p:cNvPr>
+          <p:cNvSpPr/>
+          <p:nvPr/>
+        </p:nvSpPr>
+        <p:spPr>
+          <a:xfrm>
+            <a:off x="3104228" y="2978498"/>
+            <a:ext cx="2517058" cy="2517058"/>
+          </a:xfrm>
+          <a:prstGeom prst="ellipse">
+            <a:avLst/>
+          </a:prstGeom>
+          <a:solidFill>
+            <a:srgbClr val="8FAADC"/>
+          </a:solidFill>
+        </p:spPr>
+        <p:style>
+          <a:lnRef idx="2">
+            <a:schemeClr val="accent1">
+              <a:shade val="15000"/>
+            </a:schemeClr>
+          </a:lnRef>
+          <a:fillRef idx="1">
+            <a:schemeClr val="accent1"/>
+          </a:fillRef>
+          <a:effectRef idx="0">
+            <a:schemeClr val="accent1"/>
+          </a:effectRef>
+          <a:fontRef idx="minor">
+            <a:schemeClr val="lt1"/>
+          </a:fontRef>
+        </p:style>
+        <p:txBody>
+          <a:bodyPr rtlCol="0" anchor="ctr"/>
+          <a:lstStyle/>
+          <a:p>
+            <a:pPr algn="ctr">
+              <a:spcBef>
+                <a:spcPts val="600"/>
+              </a:spcBef>
+            </a:pPr>
+            <a:r>
+              <a:rPr lang="fr-CA" sz="1000" b="1" dirty="0">
+                <a:ln>
+                  <a:solidFill>
+                    <a:schemeClr val="tx1"/>
+                  </a:solidFill>
+                </a:ln>
+                <a:latin typeface="Aptos Display" panose="020B0004020202020204" pitchFamily="34" charset="0"/>
+                <a:ea typeface="Noto Serif" panose="02020502060505020204" pitchFamily="18"/>
+                <a:cs typeface="Noto Serif" panose="02020502060505020204" pitchFamily="18"/>
+              </a:rPr>
+              <a:t>  </a:t>
+            </a:r>
+            <a:r>
+              <a:rPr lang="fr-CA" sz="22000" b="1" dirty="0">
+                <a:ln>
+                  <a:solidFill>
+                    <a:schemeClr val="tx1"/>
+                  </a:solidFill>
+                </a:ln>
+                <a:latin typeface="Aptos Display" panose="020B0004020202020204" pitchFamily="34" charset="0"/>
+                <a:ea typeface="Noto Serif" panose="02020502060505020204" pitchFamily="18"/>
+                <a:cs typeface="Noto Serif" panose="02020502060505020204" pitchFamily="18"/>
+              </a:rPr>
+              <a:t>?</a:t>
+            </a:r>
+          </a:p>
+        </p:txBody>
+      </p:sp>
       <p:grpSp>
         <p:nvGrpSpPr>
-          <p:cNvPr id="35" name="Groupe 34">
+          <p:cNvPr id="21" name="Groupe 20">
             <a:extLst>
               <a:ext uri="{FF2B5EF4-FFF2-40B4-BE49-F238E27FC236}">
-                <a16:creationId xmlns:a16="http://schemas.microsoft.com/office/drawing/2014/main" id="{64284F23-32DC-5DBB-3B68-E78F9EB3CB18}"/>
+                <a16:creationId xmlns:a16="http://schemas.microsoft.com/office/drawing/2014/main" id="{C5B4C247-3847-3F10-A4F8-C80227234CDC}"/>
               </a:ext>
             </a:extLst>
           </p:cNvPr>
@@ -9118,10 +9198,10 @@
         </p:nvGrpSpPr>
         <p:grpSpPr>
           <a:xfrm>
-            <a:off x="8997309" y="200778"/>
-            <a:ext cx="2777720" cy="3337506"/>
-            <a:chOff x="3472746" y="2876251"/>
-            <a:chExt cx="2605387" cy="3130443"/>
+            <a:off x="9006834" y="200778"/>
+            <a:ext cx="2777720" cy="2777720"/>
+            <a:chOff x="8997309" y="200778"/>
+            <a:chExt cx="2777720" cy="2777720"/>
           </a:xfrm>
         </p:grpSpPr>
         <p:grpSp>
@@ -9138,11 +9218,14 @@
           </p:nvGrpSpPr>
           <p:grpSpPr>
             <a:xfrm>
-              <a:off x="3472746" y="2876251"/>
-              <a:ext cx="2605387" cy="2605387"/>
+              <a:off x="8997309" y="200778"/>
+              <a:ext cx="2777720" cy="2777720"/>
               <a:chOff x="3383431" y="2921592"/>
               <a:chExt cx="2424516" cy="2424516"/>
             </a:xfrm>
+            <a:solidFill>
+              <a:srgbClr val="FFFF00"/>
+            </a:solidFill>
           </p:grpSpPr>
           <p:pic>
             <p:nvPicPr>
@@ -9194,19 +9277,15 @@
             </p:nvSpPr>
             <p:spPr>
               <a:xfrm>
-                <a:off x="4362757" y="3516277"/>
-                <a:ext cx="430307" cy="1427704"/>
+                <a:off x="4392735" y="3516277"/>
+                <a:ext cx="400327" cy="1427704"/>
               </a:xfrm>
               <a:prstGeom prst="rect">
                 <a:avLst/>
               </a:prstGeom>
-              <a:solidFill>
-                <a:srgbClr val="F2E600"/>
-              </a:solidFill>
-              <a:ln w="3175">
-                <a:solidFill>
-                  <a:srgbClr val="F2E600"/>
-                </a:solidFill>
+              <a:noFill/>
+              <a:ln w="57150">
+                <a:noFill/>
               </a:ln>
             </p:spPr>
             <p:style>
@@ -9237,127 +9316,176 @@
         </p:grpSp>
         <p:sp>
           <p:nvSpPr>
-            <p:cNvPr id="32" name="ZoneTexte 31">
+            <p:cNvPr id="20" name="Rectangle : coins arrondis 19">
               <a:extLst>
                 <a:ext uri="{FF2B5EF4-FFF2-40B4-BE49-F238E27FC236}">
-                  <a16:creationId xmlns:a16="http://schemas.microsoft.com/office/drawing/2014/main" id="{9FDF3485-4C8E-3053-AD8B-D4459FA42DC5}"/>
+                  <a16:creationId xmlns:a16="http://schemas.microsoft.com/office/drawing/2014/main" id="{EB5F34E0-1237-910E-8D3A-42F7430DF70E}"/>
                 </a:ext>
               </a:extLst>
             </p:cNvPr>
-            <p:cNvSpPr txBox="1"/>
+            <p:cNvSpPr/>
             <p:nvPr/>
           </p:nvSpPr>
           <p:spPr>
             <a:xfrm>
-              <a:off x="4295275" y="2959706"/>
-              <a:ext cx="960329" cy="3046988"/>
+              <a:off x="10188300" y="882097"/>
+              <a:ext cx="389344" cy="1635692"/>
             </a:xfrm>
-            <a:prstGeom prst="rect">
-              <a:avLst/>
+            <a:prstGeom prst="roundRect">
+              <a:avLst>
+                <a:gd name="adj" fmla="val 0"/>
+              </a:avLst>
             </a:prstGeom>
-            <a:noFill/>
+            <a:solidFill>
+              <a:srgbClr val="FFFF00"/>
+            </a:solidFill>
+            <a:ln w="139700">
+              <a:noFill/>
+            </a:ln>
           </p:spPr>
+          <p:style>
+            <a:lnRef idx="2">
+              <a:schemeClr val="accent1">
+                <a:shade val="15000"/>
+              </a:schemeClr>
+            </a:lnRef>
+            <a:fillRef idx="1">
+              <a:schemeClr val="accent1"/>
+            </a:fillRef>
+            <a:effectRef idx="0">
+              <a:schemeClr val="accent1"/>
+            </a:effectRef>
+            <a:fontRef idx="minor">
+              <a:schemeClr val="lt1"/>
+            </a:fontRef>
+          </p:style>
           <p:txBody>
-            <a:bodyPr wrap="square" rtlCol="0">
-              <a:spAutoFit/>
-            </a:bodyPr>
+            <a:bodyPr rtlCol="0" anchor="ctr"/>
             <a:lstStyle/>
             <a:p>
-              <a:r>
-                <a:rPr lang="fr-CA" sz="18500" b="1" dirty="0">
-                  <a:ln>
-                    <a:solidFill>
-                      <a:schemeClr val="tx1"/>
-                    </a:solidFill>
-                  </a:ln>
-                  <a:solidFill>
-                    <a:schemeClr val="bg1"/>
-                  </a:solidFill>
-                </a:rPr>
-                <a:t>!</a:t>
-              </a:r>
+              <a:pPr algn="ctr"/>
+              <a:endParaRPr lang="fr-CA"/>
+            </a:p>
+          </p:txBody>
+        </p:sp>
+        <p:sp>
+          <p:nvSpPr>
+            <p:cNvPr id="8" name="Rectangle : coins arrondis 7">
+              <a:extLst>
+                <a:ext uri="{FF2B5EF4-FFF2-40B4-BE49-F238E27FC236}">
+                  <a16:creationId xmlns:a16="http://schemas.microsoft.com/office/drawing/2014/main" id="{3DDBB0D9-9C0C-713F-1CFF-2BA2919449C4}"/>
+                </a:ext>
+              </a:extLst>
+            </p:cNvPr>
+            <p:cNvSpPr/>
+            <p:nvPr/>
+          </p:nvSpPr>
+          <p:spPr>
+            <a:xfrm>
+              <a:off x="10261986" y="2145249"/>
+              <a:ext cx="248366" cy="248445"/>
+            </a:xfrm>
+            <a:prstGeom prst="roundRect">
+              <a:avLst>
+                <a:gd name="adj" fmla="val 33334"/>
+              </a:avLst>
+            </a:prstGeom>
+            <a:solidFill>
+              <a:schemeClr val="bg1">
+                <a:lumMod val="95000"/>
+              </a:schemeClr>
+            </a:solidFill>
+            <a:ln w="76200">
+              <a:solidFill>
+                <a:schemeClr val="tx1"/>
+              </a:solidFill>
+            </a:ln>
+          </p:spPr>
+          <p:style>
+            <a:lnRef idx="2">
+              <a:schemeClr val="accent1">
+                <a:shade val="15000"/>
+              </a:schemeClr>
+            </a:lnRef>
+            <a:fillRef idx="1">
+              <a:schemeClr val="accent1"/>
+            </a:fillRef>
+            <a:effectRef idx="0">
+              <a:schemeClr val="accent1"/>
+            </a:effectRef>
+            <a:fontRef idx="minor">
+              <a:schemeClr val="lt1"/>
+            </a:fontRef>
+          </p:style>
+          <p:txBody>
+            <a:bodyPr rtlCol="0" anchor="ctr"/>
+            <a:lstStyle/>
+            <a:p>
+              <a:pPr algn="ctr"/>
+              <a:endParaRPr lang="en-CA"/>
+            </a:p>
+          </p:txBody>
+        </p:sp>
+        <p:sp>
+          <p:nvSpPr>
+            <p:cNvPr id="11" name="Rectangle : avec coins rognés en haut 10">
+              <a:extLst>
+                <a:ext uri="{FF2B5EF4-FFF2-40B4-BE49-F238E27FC236}">
+                  <a16:creationId xmlns:a16="http://schemas.microsoft.com/office/drawing/2014/main" id="{33945E3D-D3B3-9AEE-DFD7-22DAE87AD36F}"/>
+                </a:ext>
+              </a:extLst>
+            </p:cNvPr>
+            <p:cNvSpPr/>
+            <p:nvPr/>
+          </p:nvSpPr>
+          <p:spPr>
+            <a:xfrm rot="10800000">
+              <a:off x="10261986" y="954073"/>
+              <a:ext cx="248366" cy="992616"/>
+            </a:xfrm>
+            <a:prstGeom prst="snip2SameRect">
+              <a:avLst>
+                <a:gd name="adj1" fmla="val 24126"/>
+                <a:gd name="adj2" fmla="val 12622"/>
+              </a:avLst>
+            </a:prstGeom>
+            <a:solidFill>
+              <a:schemeClr val="bg1">
+                <a:lumMod val="95000"/>
+              </a:schemeClr>
+            </a:solidFill>
+            <a:ln w="76200">
+              <a:solidFill>
+                <a:schemeClr val="tx1"/>
+              </a:solidFill>
+            </a:ln>
+          </p:spPr>
+          <p:style>
+            <a:lnRef idx="2">
+              <a:schemeClr val="accent1">
+                <a:shade val="15000"/>
+              </a:schemeClr>
+            </a:lnRef>
+            <a:fillRef idx="1">
+              <a:schemeClr val="accent1"/>
+            </a:fillRef>
+            <a:effectRef idx="0">
+              <a:schemeClr val="accent1"/>
+            </a:effectRef>
+            <a:fontRef idx="minor">
+              <a:schemeClr val="lt1"/>
+            </a:fontRef>
+          </p:style>
+          <p:txBody>
+            <a:bodyPr rtlCol="0" anchor="ctr"/>
+            <a:lstStyle/>
+            <a:p>
+              <a:pPr algn="ctr"/>
+              <a:endParaRPr lang="en-CA"/>
             </a:p>
           </p:txBody>
         </p:sp>
       </p:grpSp>
-      <p:sp>
-        <p:nvSpPr>
-          <p:cNvPr id="4" name="Ellipse 3">
-            <a:extLst>
-              <a:ext uri="{FF2B5EF4-FFF2-40B4-BE49-F238E27FC236}">
-                <a16:creationId xmlns:a16="http://schemas.microsoft.com/office/drawing/2014/main" id="{4681F7E5-A3DB-1479-3EEA-0D1191E58396}"/>
-              </a:ext>
-            </a:extLst>
-          </p:cNvPr>
-          <p:cNvSpPr/>
-          <p:nvPr/>
-        </p:nvSpPr>
-        <p:spPr>
-          <a:xfrm>
-            <a:off x="3104228" y="2978498"/>
-            <a:ext cx="2517058" cy="2517058"/>
-          </a:xfrm>
-          <a:prstGeom prst="ellipse">
-            <a:avLst/>
-          </a:prstGeom>
-          <a:solidFill>
-            <a:srgbClr val="8FAADC"/>
-          </a:solidFill>
-        </p:spPr>
-        <p:style>
-          <a:lnRef idx="2">
-            <a:schemeClr val="accent1">
-              <a:shade val="15000"/>
-            </a:schemeClr>
-          </a:lnRef>
-          <a:fillRef idx="1">
-            <a:schemeClr val="accent1"/>
-          </a:fillRef>
-          <a:effectRef idx="0">
-            <a:schemeClr val="accent1"/>
-          </a:effectRef>
-          <a:fontRef idx="minor">
-            <a:schemeClr val="lt1"/>
-          </a:fontRef>
-        </p:style>
-        <p:txBody>
-          <a:bodyPr rtlCol="0" anchor="ctr"/>
-          <a:lstStyle/>
-          <a:p>
-            <a:pPr algn="ctr">
-              <a:spcBef>
-                <a:spcPts val="600"/>
-              </a:spcBef>
-            </a:pPr>
-            <a:r>
-              <a:rPr lang="fr-CA" sz="1000" b="1" dirty="0">
-                <a:ln>
-                  <a:solidFill>
-                    <a:schemeClr val="tx1"/>
-                  </a:solidFill>
-                </a:ln>
-                <a:latin typeface="Aptos Display" panose="020B0004020202020204" pitchFamily="34" charset="0"/>
-                <a:ea typeface="Noto Serif" panose="02020502060505020204" pitchFamily="18"/>
-                <a:cs typeface="Noto Serif" panose="02020502060505020204" pitchFamily="18"/>
-              </a:rPr>
-              <a:t>  </a:t>
-            </a:r>
-            <a:r>
-              <a:rPr lang="fr-CA" sz="22000" b="1" dirty="0">
-                <a:ln>
-                  <a:solidFill>
-                    <a:schemeClr val="tx1"/>
-                  </a:solidFill>
-                </a:ln>
-                <a:latin typeface="Aptos Display" panose="020B0004020202020204" pitchFamily="34" charset="0"/>
-                <a:ea typeface="Noto Serif" panose="02020502060505020204" pitchFamily="18"/>
-                <a:cs typeface="Noto Serif" panose="02020502060505020204" pitchFamily="18"/>
-              </a:rPr>
-              <a:t>?</a:t>
-            </a:r>
-          </a:p>
-        </p:txBody>
-      </p:sp>
     </p:spTree>
     <p:extLst>
       <p:ext uri="{BB962C8B-B14F-4D97-AF65-F5344CB8AC3E}">
@@ -16034,7 +16162,7 @@
         </p:nvGrpSpPr>
         <p:grpSpPr>
           <a:xfrm>
-            <a:off x="8696100" y="-175400"/>
+            <a:off x="5910432" y="-497550"/>
             <a:ext cx="3159354" cy="4894095"/>
             <a:chOff x="5986431" y="1491165"/>
             <a:chExt cx="3159354" cy="4894095"/>
@@ -17665,7 +17793,7 @@
         </p:nvGrpSpPr>
         <p:grpSpPr>
           <a:xfrm>
-            <a:off x="3699583" y="4220269"/>
+            <a:off x="3629458" y="2346002"/>
             <a:ext cx="1848051" cy="1848051"/>
             <a:chOff x="3699583" y="4220269"/>
             <a:chExt cx="1848051" cy="1848051"/>
@@ -17857,10 +17985,1194 @@
           </p:cxnSp>
         </p:grpSp>
       </p:grpSp>
+      <p:grpSp>
+        <p:nvGrpSpPr>
+          <p:cNvPr id="40" name="Groupe 39">
+            <a:extLst>
+              <a:ext uri="{FF2B5EF4-FFF2-40B4-BE49-F238E27FC236}">
+                <a16:creationId xmlns:a16="http://schemas.microsoft.com/office/drawing/2014/main" id="{0C807909-694C-48E2-8143-D22AE60CA5B0}"/>
+              </a:ext>
+            </a:extLst>
+          </p:cNvPr>
+          <p:cNvGrpSpPr/>
+          <p:nvPr/>
+        </p:nvGrpSpPr>
+        <p:grpSpPr>
+          <a:xfrm>
+            <a:off x="3753743" y="4796700"/>
+            <a:ext cx="1723766" cy="1731267"/>
+            <a:chOff x="7149517" y="4041575"/>
+            <a:chExt cx="1723766" cy="1731267"/>
+          </a:xfrm>
+        </p:grpSpPr>
+        <p:cxnSp>
+          <p:nvCxnSpPr>
+            <p:cNvPr id="24" name="Connecteur droit avec flèche 23">
+              <a:extLst>
+                <a:ext uri="{FF2B5EF4-FFF2-40B4-BE49-F238E27FC236}">
+                  <a16:creationId xmlns:a16="http://schemas.microsoft.com/office/drawing/2014/main" id="{5147A507-7533-AC79-EE31-36BE616EB885}"/>
+                </a:ext>
+              </a:extLst>
+            </p:cNvPr>
+            <p:cNvCxnSpPr>
+              <a:cxnSpLocks/>
+            </p:cNvCxnSpPr>
+            <p:nvPr/>
+          </p:nvCxnSpPr>
+          <p:spPr>
+            <a:xfrm flipH="1">
+              <a:off x="7506689" y="4090737"/>
+              <a:ext cx="10642" cy="1643313"/>
+            </a:xfrm>
+            <a:prstGeom prst="straightConnector1">
+              <a:avLst/>
+            </a:prstGeom>
+            <a:ln w="152400" cap="rnd">
+              <a:solidFill>
+                <a:schemeClr val="tx1"/>
+              </a:solidFill>
+              <a:headEnd type="triangle"/>
+              <a:tailEnd type="triangle"/>
+            </a:ln>
+          </p:spPr>
+          <p:style>
+            <a:lnRef idx="1">
+              <a:schemeClr val="accent1"/>
+            </a:lnRef>
+            <a:fillRef idx="0">
+              <a:schemeClr val="accent1"/>
+            </a:fillRef>
+            <a:effectRef idx="0">
+              <a:schemeClr val="accent1"/>
+            </a:effectRef>
+            <a:fontRef idx="minor">
+              <a:schemeClr val="tx1"/>
+            </a:fontRef>
+          </p:style>
+        </p:cxnSp>
+        <p:sp>
+          <p:nvSpPr>
+            <p:cNvPr id="25" name="ZoneTexte 24">
+              <a:extLst>
+                <a:ext uri="{FF2B5EF4-FFF2-40B4-BE49-F238E27FC236}">
+                  <a16:creationId xmlns:a16="http://schemas.microsoft.com/office/drawing/2014/main" id="{761FF51F-DA73-E6DC-B68A-D177342CAF07}"/>
+                </a:ext>
+              </a:extLst>
+            </p:cNvPr>
+            <p:cNvSpPr txBox="1"/>
+            <p:nvPr/>
+          </p:nvSpPr>
+          <p:spPr>
+            <a:xfrm>
+              <a:off x="7946426" y="4304561"/>
+              <a:ext cx="926857" cy="1323439"/>
+            </a:xfrm>
+            <a:prstGeom prst="rect">
+              <a:avLst/>
+            </a:prstGeom>
+            <a:noFill/>
+          </p:spPr>
+          <p:txBody>
+            <a:bodyPr wrap="none" rtlCol="0">
+              <a:spAutoFit/>
+            </a:bodyPr>
+            <a:lstStyle/>
+            <a:p>
+              <a:r>
+                <a:rPr lang="en-CA" sz="8000" b="1" dirty="0">
+                  <a:latin typeface="DejaVu Sans" panose="020B0603030804020204" pitchFamily="34" charset="0"/>
+                  <a:ea typeface="DejaVu Sans" panose="020B0603030804020204" pitchFamily="34" charset="0"/>
+                  <a:cs typeface="DejaVu Sans" panose="020B0603030804020204" pitchFamily="34" charset="0"/>
+                </a:rPr>
+                <a:t>Y</a:t>
+              </a:r>
+            </a:p>
+          </p:txBody>
+        </p:sp>
+        <p:cxnSp>
+          <p:nvCxnSpPr>
+            <p:cNvPr id="29" name="Connecteur droit 28">
+              <a:extLst>
+                <a:ext uri="{FF2B5EF4-FFF2-40B4-BE49-F238E27FC236}">
+                  <a16:creationId xmlns:a16="http://schemas.microsoft.com/office/drawing/2014/main" id="{669D8279-5C49-A9EC-C982-6691525F8774}"/>
+                </a:ext>
+              </a:extLst>
+            </p:cNvPr>
+            <p:cNvCxnSpPr>
+              <a:cxnSpLocks/>
+            </p:cNvCxnSpPr>
+            <p:nvPr/>
+          </p:nvCxnSpPr>
+          <p:spPr>
+            <a:xfrm flipH="1">
+              <a:off x="7149518" y="4041575"/>
+              <a:ext cx="1242007" cy="0"/>
+            </a:xfrm>
+            <a:prstGeom prst="line">
+              <a:avLst/>
+            </a:prstGeom>
+            <a:ln w="127000" cap="rnd">
+              <a:solidFill>
+                <a:schemeClr val="tx1"/>
+              </a:solidFill>
+            </a:ln>
+          </p:spPr>
+          <p:style>
+            <a:lnRef idx="1">
+              <a:schemeClr val="accent1"/>
+            </a:lnRef>
+            <a:fillRef idx="0">
+              <a:schemeClr val="accent1"/>
+            </a:fillRef>
+            <a:effectRef idx="0">
+              <a:schemeClr val="accent1"/>
+            </a:effectRef>
+            <a:fontRef idx="minor">
+              <a:schemeClr val="tx1"/>
+            </a:fontRef>
+          </p:style>
+        </p:cxnSp>
+        <p:cxnSp>
+          <p:nvCxnSpPr>
+            <p:cNvPr id="31" name="Connecteur droit 30">
+              <a:extLst>
+                <a:ext uri="{FF2B5EF4-FFF2-40B4-BE49-F238E27FC236}">
+                  <a16:creationId xmlns:a16="http://schemas.microsoft.com/office/drawing/2014/main" id="{2CCEC863-6B5B-E31D-287D-B2AD2F87E672}"/>
+                </a:ext>
+              </a:extLst>
+            </p:cNvPr>
+            <p:cNvCxnSpPr>
+              <a:cxnSpLocks/>
+            </p:cNvCxnSpPr>
+            <p:nvPr/>
+          </p:nvCxnSpPr>
+          <p:spPr>
+            <a:xfrm flipH="1">
+              <a:off x="7149517" y="5772842"/>
+              <a:ext cx="1242008" cy="0"/>
+            </a:xfrm>
+            <a:prstGeom prst="line">
+              <a:avLst/>
+            </a:prstGeom>
+            <a:ln w="127000" cap="rnd">
+              <a:solidFill>
+                <a:schemeClr val="tx1"/>
+              </a:solidFill>
+            </a:ln>
+          </p:spPr>
+          <p:style>
+            <a:lnRef idx="1">
+              <a:schemeClr val="accent1"/>
+            </a:lnRef>
+            <a:fillRef idx="0">
+              <a:schemeClr val="accent1"/>
+            </a:fillRef>
+            <a:effectRef idx="0">
+              <a:schemeClr val="accent1"/>
+            </a:effectRef>
+            <a:fontRef idx="minor">
+              <a:schemeClr val="tx1"/>
+            </a:fontRef>
+          </p:style>
+        </p:cxnSp>
+      </p:grpSp>
+      <p:grpSp>
+        <p:nvGrpSpPr>
+          <p:cNvPr id="45" name="Groupe 44">
+            <a:extLst>
+              <a:ext uri="{FF2B5EF4-FFF2-40B4-BE49-F238E27FC236}">
+                <a16:creationId xmlns:a16="http://schemas.microsoft.com/office/drawing/2014/main" id="{157710FA-9069-88B6-659B-D92B4E215526}"/>
+              </a:ext>
+            </a:extLst>
+          </p:cNvPr>
+          <p:cNvGrpSpPr/>
+          <p:nvPr/>
+        </p:nvGrpSpPr>
+        <p:grpSpPr>
+          <a:xfrm>
+            <a:off x="8617633" y="625034"/>
+            <a:ext cx="3104786" cy="3162299"/>
+            <a:chOff x="8531458" y="378718"/>
+            <a:chExt cx="3104786" cy="3162299"/>
+          </a:xfrm>
+        </p:grpSpPr>
+        <p:grpSp>
+          <p:nvGrpSpPr>
+            <p:cNvPr id="46" name="Groupe 45">
+              <a:extLst>
+                <a:ext uri="{FF2B5EF4-FFF2-40B4-BE49-F238E27FC236}">
+                  <a16:creationId xmlns:a16="http://schemas.microsoft.com/office/drawing/2014/main" id="{0C65B518-6D94-57FB-76F9-7D2363FBC88F}"/>
+                </a:ext>
+              </a:extLst>
+            </p:cNvPr>
+            <p:cNvGrpSpPr/>
+            <p:nvPr/>
+          </p:nvGrpSpPr>
+          <p:grpSpPr>
+            <a:xfrm>
+              <a:off x="8531458" y="378718"/>
+              <a:ext cx="3104786" cy="3162299"/>
+              <a:chOff x="567328" y="408215"/>
+              <a:chExt cx="3889829" cy="3960000"/>
+            </a:xfrm>
+          </p:grpSpPr>
+          <p:sp>
+            <p:nvSpPr>
+              <p:cNvPr id="49" name="Rectangle : coins arrondis 48">
+                <a:extLst>
+                  <a:ext uri="{FF2B5EF4-FFF2-40B4-BE49-F238E27FC236}">
+                    <a16:creationId xmlns:a16="http://schemas.microsoft.com/office/drawing/2014/main" id="{9950D84D-0E9A-C5E1-83AD-1827F99B9B25}"/>
+                  </a:ext>
+                </a:extLst>
+              </p:cNvPr>
+              <p:cNvSpPr/>
+              <p:nvPr/>
+            </p:nvSpPr>
+            <p:spPr>
+              <a:xfrm>
+                <a:off x="1072243" y="408215"/>
+                <a:ext cx="2880000" cy="3960000"/>
+              </a:xfrm>
+              <a:prstGeom prst="roundRect">
+                <a:avLst>
+                  <a:gd name="adj" fmla="val 2997"/>
+                </a:avLst>
+              </a:prstGeom>
+              <a:solidFill>
+                <a:schemeClr val="bg1"/>
+              </a:solidFill>
+              <a:ln w="177800">
+                <a:solidFill>
+                  <a:srgbClr val="2F528F"/>
+                </a:solidFill>
+              </a:ln>
+            </p:spPr>
+            <p:style>
+              <a:lnRef idx="2">
+                <a:schemeClr val="accent1">
+                  <a:shade val="15000"/>
+                </a:schemeClr>
+              </a:lnRef>
+              <a:fillRef idx="1">
+                <a:schemeClr val="accent1"/>
+              </a:fillRef>
+              <a:effectRef idx="0">
+                <a:schemeClr val="accent1"/>
+              </a:effectRef>
+              <a:fontRef idx="minor">
+                <a:schemeClr val="lt1"/>
+              </a:fontRef>
+            </p:style>
+            <p:txBody>
+              <a:bodyPr rtlCol="0" anchor="ctr"/>
+              <a:lstStyle/>
+              <a:p>
+                <a:pPr algn="ctr"/>
+                <a:endParaRPr lang="fr-CA"/>
+              </a:p>
+            </p:txBody>
+          </p:sp>
+          <p:sp>
+            <p:nvSpPr>
+              <p:cNvPr id="50" name="Rectangle 49">
+                <a:extLst>
+                  <a:ext uri="{FF2B5EF4-FFF2-40B4-BE49-F238E27FC236}">
+                    <a16:creationId xmlns:a16="http://schemas.microsoft.com/office/drawing/2014/main" id="{58F58EB1-4B81-019A-4D4C-F42DAC87782B}"/>
+                  </a:ext>
+                </a:extLst>
+              </p:cNvPr>
+              <p:cNvSpPr/>
+              <p:nvPr/>
+            </p:nvSpPr>
+            <p:spPr>
+              <a:xfrm>
+                <a:off x="567328" y="2562226"/>
+                <a:ext cx="3889829" cy="1240064"/>
+              </a:xfrm>
+              <a:prstGeom prst="rect">
+                <a:avLst/>
+              </a:prstGeom>
+              <a:solidFill>
+                <a:srgbClr val="8FAADC"/>
+              </a:solidFill>
+              <a:ln w="190500">
+                <a:solidFill>
+                  <a:srgbClr val="2F528F"/>
+                </a:solidFill>
+              </a:ln>
+              <a:effectLst>
+                <a:glow>
+                  <a:schemeClr val="accent1">
+                    <a:alpha val="40000"/>
+                  </a:schemeClr>
+                </a:glow>
+                <a:softEdge rad="0"/>
+              </a:effectLst>
+            </p:spPr>
+            <p:style>
+              <a:lnRef idx="2">
+                <a:schemeClr val="accent6">
+                  <a:shade val="15000"/>
+                </a:schemeClr>
+              </a:lnRef>
+              <a:fillRef idx="1">
+                <a:schemeClr val="accent6"/>
+              </a:fillRef>
+              <a:effectRef idx="0">
+                <a:schemeClr val="accent6"/>
+              </a:effectRef>
+              <a:fontRef idx="minor">
+                <a:schemeClr val="lt1"/>
+              </a:fontRef>
+            </p:style>
+            <p:txBody>
+              <a:bodyPr rtlCol="0" anchor="ctr"/>
+              <a:lstStyle/>
+              <a:p>
+                <a:pPr algn="ctr"/>
+                <a:r>
+                  <a:rPr lang="fr-CA" sz="7000" b="1" dirty="0" err="1">
+                    <a:solidFill>
+                      <a:schemeClr val="bg1"/>
+                    </a:solidFill>
+                    <a:latin typeface="DejaVu Sans" panose="020B0603030804020204" pitchFamily="34" charset="0"/>
+                    <a:ea typeface="DejaVu Sans" panose="020B0603030804020204" pitchFamily="34" charset="0"/>
+                    <a:cs typeface="DejaVu Sans" panose="020B0603030804020204" pitchFamily="34" charset="0"/>
+                  </a:rPr>
+                  <a:t>scval</a:t>
+                </a:r>
+                <a:endParaRPr lang="fr-CA" sz="7000" b="1" dirty="0">
+                  <a:solidFill>
+                    <a:schemeClr val="bg1"/>
+                  </a:solidFill>
+                  <a:latin typeface="DejaVu Sans" panose="020B0603030804020204" pitchFamily="34" charset="0"/>
+                  <a:ea typeface="DejaVu Sans" panose="020B0603030804020204" pitchFamily="34" charset="0"/>
+                  <a:cs typeface="DejaVu Sans" panose="020B0603030804020204" pitchFamily="34" charset="0"/>
+                </a:endParaRPr>
+              </a:p>
+            </p:txBody>
+          </p:sp>
+          <p:cxnSp>
+            <p:nvCxnSpPr>
+              <p:cNvPr id="51" name="Connecteur droit 50">
+                <a:extLst>
+                  <a:ext uri="{FF2B5EF4-FFF2-40B4-BE49-F238E27FC236}">
+                    <a16:creationId xmlns:a16="http://schemas.microsoft.com/office/drawing/2014/main" id="{7728EE1A-ACCA-81A0-9C55-10EF013ADE80}"/>
+                  </a:ext>
+                </a:extLst>
+              </p:cNvPr>
+              <p:cNvCxnSpPr/>
+              <p:nvPr/>
+            </p:nvCxnSpPr>
+            <p:spPr>
+              <a:xfrm>
+                <a:off x="1613762" y="939288"/>
+                <a:ext cx="1582057" cy="0"/>
+              </a:xfrm>
+              <a:prstGeom prst="line">
+                <a:avLst/>
+              </a:prstGeom>
+              <a:ln w="139700" cap="rnd">
+                <a:solidFill>
+                  <a:srgbClr val="2F528F"/>
+                </a:solidFill>
+              </a:ln>
+            </p:spPr>
+            <p:style>
+              <a:lnRef idx="1">
+                <a:schemeClr val="accent1"/>
+              </a:lnRef>
+              <a:fillRef idx="0">
+                <a:schemeClr val="accent1"/>
+              </a:fillRef>
+              <a:effectRef idx="0">
+                <a:schemeClr val="accent1"/>
+              </a:effectRef>
+              <a:fontRef idx="minor">
+                <a:schemeClr val="tx1"/>
+              </a:fontRef>
+            </p:style>
+          </p:cxnSp>
+        </p:grpSp>
+        <p:cxnSp>
+          <p:nvCxnSpPr>
+            <p:cNvPr id="47" name="Connecteur droit 46">
+              <a:extLst>
+                <a:ext uri="{FF2B5EF4-FFF2-40B4-BE49-F238E27FC236}">
+                  <a16:creationId xmlns:a16="http://schemas.microsoft.com/office/drawing/2014/main" id="{B5209644-F71B-B89D-A38C-6527A3444238}"/>
+                </a:ext>
+              </a:extLst>
+            </p:cNvPr>
+            <p:cNvCxnSpPr/>
+            <p:nvPr/>
+          </p:nvCxnSpPr>
+          <p:spPr>
+            <a:xfrm>
+              <a:off x="9366701" y="1269845"/>
+              <a:ext cx="1262767" cy="0"/>
+            </a:xfrm>
+            <a:prstGeom prst="line">
+              <a:avLst/>
+            </a:prstGeom>
+            <a:ln w="139700" cap="rnd">
+              <a:solidFill>
+                <a:srgbClr val="2F528F"/>
+              </a:solidFill>
+            </a:ln>
+          </p:spPr>
+          <p:style>
+            <a:lnRef idx="1">
+              <a:schemeClr val="accent1"/>
+            </a:lnRef>
+            <a:fillRef idx="0">
+              <a:schemeClr val="accent1"/>
+            </a:fillRef>
+            <a:effectRef idx="0">
+              <a:schemeClr val="accent1"/>
+            </a:effectRef>
+            <a:fontRef idx="minor">
+              <a:schemeClr val="tx1"/>
+            </a:fontRef>
+          </p:style>
+        </p:cxnSp>
+        <p:cxnSp>
+          <p:nvCxnSpPr>
+            <p:cNvPr id="48" name="Connecteur droit 47">
+              <a:extLst>
+                <a:ext uri="{FF2B5EF4-FFF2-40B4-BE49-F238E27FC236}">
+                  <a16:creationId xmlns:a16="http://schemas.microsoft.com/office/drawing/2014/main" id="{C2DE41F9-FF19-0D18-591E-60A6718C7E06}"/>
+                </a:ext>
+              </a:extLst>
+            </p:cNvPr>
+            <p:cNvCxnSpPr/>
+            <p:nvPr/>
+          </p:nvCxnSpPr>
+          <p:spPr>
+            <a:xfrm>
+              <a:off x="9366701" y="1731960"/>
+              <a:ext cx="1262767" cy="0"/>
+            </a:xfrm>
+            <a:prstGeom prst="line">
+              <a:avLst/>
+            </a:prstGeom>
+            <a:ln w="139700" cap="rnd">
+              <a:solidFill>
+                <a:srgbClr val="2F528F"/>
+              </a:solidFill>
+            </a:ln>
+          </p:spPr>
+          <p:style>
+            <a:lnRef idx="1">
+              <a:schemeClr val="accent1"/>
+            </a:lnRef>
+            <a:fillRef idx="0">
+              <a:schemeClr val="accent1"/>
+            </a:fillRef>
+            <a:effectRef idx="0">
+              <a:schemeClr val="accent1"/>
+            </a:effectRef>
+            <a:fontRef idx="minor">
+              <a:schemeClr val="tx1"/>
+            </a:fontRef>
+          </p:style>
+        </p:cxnSp>
+      </p:grpSp>
     </p:spTree>
     <p:extLst>
       <p:ext uri="{BB962C8B-B14F-4D97-AF65-F5344CB8AC3E}">
         <p14:creationId xmlns:p14="http://schemas.microsoft.com/office/powerpoint/2010/main" val="3550470372"/>
+      </p:ext>
+    </p:extLst>
+  </p:cSld>
+  <p:clrMapOvr>
+    <a:masterClrMapping/>
+  </p:clrMapOvr>
+</p:sld>
+</file>
+
+<file path=ppt/slides/slide9.xml><?xml version="1.0" encoding="utf-8"?>
+<p:sld xmlns:a="http://schemas.openxmlformats.org/drawingml/2006/main" xmlns:r="http://schemas.openxmlformats.org/officeDocument/2006/relationships" xmlns:p="http://schemas.openxmlformats.org/presentationml/2006/main">
+  <p:cSld>
+    <p:spTree>
+      <p:nvGrpSpPr>
+        <p:cNvPr id="1" name=""/>
+        <p:cNvGrpSpPr/>
+        <p:nvPr/>
+      </p:nvGrpSpPr>
+      <p:grpSpPr>
+        <a:xfrm>
+          <a:off x="0" y="0"/>
+          <a:ext cx="0" cy="0"/>
+          <a:chOff x="0" y="0"/>
+          <a:chExt cx="0" cy="0"/>
+        </a:xfrm>
+      </p:grpSpPr>
+      <p:grpSp>
+        <p:nvGrpSpPr>
+          <p:cNvPr id="8" name="Groupe 7">
+            <a:extLst>
+              <a:ext uri="{FF2B5EF4-FFF2-40B4-BE49-F238E27FC236}">
+                <a16:creationId xmlns:a16="http://schemas.microsoft.com/office/drawing/2014/main" id="{7252CEEE-CBC4-AF76-1AB4-9F87A4D5E203}"/>
+              </a:ext>
+            </a:extLst>
+          </p:cNvPr>
+          <p:cNvGrpSpPr/>
+          <p:nvPr/>
+        </p:nvGrpSpPr>
+        <p:grpSpPr>
+          <a:xfrm>
+            <a:off x="586550" y="570132"/>
+            <a:ext cx="1699855" cy="1611093"/>
+            <a:chOff x="5322094" y="2762250"/>
+            <a:chExt cx="1163261" cy="1102519"/>
+          </a:xfrm>
+          <a:solidFill>
+            <a:schemeClr val="accent4">
+              <a:lumMod val="60000"/>
+              <a:lumOff val="40000"/>
+            </a:schemeClr>
+          </a:solidFill>
+        </p:grpSpPr>
+        <p:sp>
+          <p:nvSpPr>
+            <p:cNvPr id="7" name="Forme libre : forme 6">
+              <a:extLst>
+                <a:ext uri="{FF2B5EF4-FFF2-40B4-BE49-F238E27FC236}">
+                  <a16:creationId xmlns:a16="http://schemas.microsoft.com/office/drawing/2014/main" id="{57DF3538-558F-6BC6-E117-4E7B05DF4CA9}"/>
+                </a:ext>
+              </a:extLst>
+            </p:cNvPr>
+            <p:cNvSpPr/>
+            <p:nvPr/>
+          </p:nvSpPr>
+          <p:spPr>
+            <a:xfrm>
+              <a:off x="5322094" y="2762250"/>
+              <a:ext cx="1030664" cy="1102519"/>
+            </a:xfrm>
+            <a:custGeom>
+              <a:avLst/>
+              <a:gdLst>
+                <a:gd name="csX0" fmla="*/ 26194 w 1026319"/>
+                <a:gd name="csY0" fmla="*/ 1102519 h 1102519"/>
+                <a:gd name="csX1" fmla="*/ 0 w 1026319"/>
+                <a:gd name="csY1" fmla="*/ 135731 h 1102519"/>
+                <a:gd name="csX2" fmla="*/ 116681 w 1026319"/>
+                <a:gd name="csY2" fmla="*/ 14288 h 1102519"/>
+                <a:gd name="csX3" fmla="*/ 397669 w 1026319"/>
+                <a:gd name="csY3" fmla="*/ 0 h 1102519"/>
+                <a:gd name="csX4" fmla="*/ 538162 w 1026319"/>
+                <a:gd name="csY4" fmla="*/ 130969 h 1102519"/>
+                <a:gd name="csX5" fmla="*/ 1023937 w 1026319"/>
+                <a:gd name="csY5" fmla="*/ 71438 h 1102519"/>
+                <a:gd name="csX6" fmla="*/ 1026319 w 1026319"/>
+                <a:gd name="csY6" fmla="*/ 180975 h 1102519"/>
+                <a:gd name="csX7" fmla="*/ 595312 w 1026319"/>
+                <a:gd name="csY7" fmla="*/ 219075 h 1102519"/>
+                <a:gd name="csX8" fmla="*/ 459581 w 1026319"/>
+                <a:gd name="csY8" fmla="*/ 323850 h 1102519"/>
+                <a:gd name="csX9" fmla="*/ 128587 w 1026319"/>
+                <a:gd name="csY9" fmla="*/ 354806 h 1102519"/>
+                <a:gd name="csX10" fmla="*/ 26194 w 1026319"/>
+                <a:gd name="csY10" fmla="*/ 1102519 h 1102519"/>
+                <a:gd name="csX0" fmla="*/ 26194 w 1026319"/>
+                <a:gd name="csY0" fmla="*/ 1102519 h 1102519"/>
+                <a:gd name="csX1" fmla="*/ 0 w 1026319"/>
+                <a:gd name="csY1" fmla="*/ 135731 h 1102519"/>
+                <a:gd name="csX2" fmla="*/ 116681 w 1026319"/>
+                <a:gd name="csY2" fmla="*/ 14288 h 1102519"/>
+                <a:gd name="csX3" fmla="*/ 397669 w 1026319"/>
+                <a:gd name="csY3" fmla="*/ 0 h 1102519"/>
+                <a:gd name="csX4" fmla="*/ 546853 w 1026319"/>
+                <a:gd name="csY4" fmla="*/ 109242 h 1102519"/>
+                <a:gd name="csX5" fmla="*/ 1023937 w 1026319"/>
+                <a:gd name="csY5" fmla="*/ 71438 h 1102519"/>
+                <a:gd name="csX6" fmla="*/ 1026319 w 1026319"/>
+                <a:gd name="csY6" fmla="*/ 180975 h 1102519"/>
+                <a:gd name="csX7" fmla="*/ 595312 w 1026319"/>
+                <a:gd name="csY7" fmla="*/ 219075 h 1102519"/>
+                <a:gd name="csX8" fmla="*/ 459581 w 1026319"/>
+                <a:gd name="csY8" fmla="*/ 323850 h 1102519"/>
+                <a:gd name="csX9" fmla="*/ 128587 w 1026319"/>
+                <a:gd name="csY9" fmla="*/ 354806 h 1102519"/>
+                <a:gd name="csX10" fmla="*/ 26194 w 1026319"/>
+                <a:gd name="csY10" fmla="*/ 1102519 h 1102519"/>
+                <a:gd name="csX0" fmla="*/ 26194 w 1030664"/>
+                <a:gd name="csY0" fmla="*/ 1102519 h 1102519"/>
+                <a:gd name="csX1" fmla="*/ 0 w 1030664"/>
+                <a:gd name="csY1" fmla="*/ 135731 h 1102519"/>
+                <a:gd name="csX2" fmla="*/ 116681 w 1030664"/>
+                <a:gd name="csY2" fmla="*/ 14288 h 1102519"/>
+                <a:gd name="csX3" fmla="*/ 397669 w 1030664"/>
+                <a:gd name="csY3" fmla="*/ 0 h 1102519"/>
+                <a:gd name="csX4" fmla="*/ 546853 w 1030664"/>
+                <a:gd name="csY4" fmla="*/ 109242 h 1102519"/>
+                <a:gd name="csX5" fmla="*/ 1023937 w 1030664"/>
+                <a:gd name="csY5" fmla="*/ 71438 h 1102519"/>
+                <a:gd name="csX6" fmla="*/ 1030664 w 1030664"/>
+                <a:gd name="csY6" fmla="*/ 217912 h 1102519"/>
+                <a:gd name="csX7" fmla="*/ 595312 w 1030664"/>
+                <a:gd name="csY7" fmla="*/ 219075 h 1102519"/>
+                <a:gd name="csX8" fmla="*/ 459581 w 1030664"/>
+                <a:gd name="csY8" fmla="*/ 323850 h 1102519"/>
+                <a:gd name="csX9" fmla="*/ 128587 w 1030664"/>
+                <a:gd name="csY9" fmla="*/ 354806 h 1102519"/>
+                <a:gd name="csX10" fmla="*/ 26194 w 1030664"/>
+                <a:gd name="csY10" fmla="*/ 1102519 h 1102519"/>
+                <a:gd name="csX0" fmla="*/ 26194 w 1030664"/>
+                <a:gd name="csY0" fmla="*/ 1102519 h 1102519"/>
+                <a:gd name="csX1" fmla="*/ 0 w 1030664"/>
+                <a:gd name="csY1" fmla="*/ 135731 h 1102519"/>
+                <a:gd name="csX2" fmla="*/ 116681 w 1030664"/>
+                <a:gd name="csY2" fmla="*/ 14288 h 1102519"/>
+                <a:gd name="csX3" fmla="*/ 397669 w 1030664"/>
+                <a:gd name="csY3" fmla="*/ 0 h 1102519"/>
+                <a:gd name="csX4" fmla="*/ 546853 w 1030664"/>
+                <a:gd name="csY4" fmla="*/ 109242 h 1102519"/>
+                <a:gd name="csX5" fmla="*/ 1023937 w 1030664"/>
+                <a:gd name="csY5" fmla="*/ 71438 h 1102519"/>
+                <a:gd name="csX6" fmla="*/ 1030664 w 1030664"/>
+                <a:gd name="csY6" fmla="*/ 217912 h 1102519"/>
+                <a:gd name="csX7" fmla="*/ 599657 w 1030664"/>
+                <a:gd name="csY7" fmla="*/ 240803 h 1102519"/>
+                <a:gd name="csX8" fmla="*/ 459581 w 1030664"/>
+                <a:gd name="csY8" fmla="*/ 323850 h 1102519"/>
+                <a:gd name="csX9" fmla="*/ 128587 w 1030664"/>
+                <a:gd name="csY9" fmla="*/ 354806 h 1102519"/>
+                <a:gd name="csX10" fmla="*/ 26194 w 1030664"/>
+                <a:gd name="csY10" fmla="*/ 1102519 h 1102519"/>
+                <a:gd name="csX0" fmla="*/ 26194 w 1030664"/>
+                <a:gd name="csY0" fmla="*/ 1102519 h 1102519"/>
+                <a:gd name="csX1" fmla="*/ 0 w 1030664"/>
+                <a:gd name="csY1" fmla="*/ 135731 h 1102519"/>
+                <a:gd name="csX2" fmla="*/ 116681 w 1030664"/>
+                <a:gd name="csY2" fmla="*/ 14288 h 1102519"/>
+                <a:gd name="csX3" fmla="*/ 397669 w 1030664"/>
+                <a:gd name="csY3" fmla="*/ 0 h 1102519"/>
+                <a:gd name="csX4" fmla="*/ 546853 w 1030664"/>
+                <a:gd name="csY4" fmla="*/ 109242 h 1102519"/>
+                <a:gd name="csX5" fmla="*/ 1023937 w 1030664"/>
+                <a:gd name="csY5" fmla="*/ 71438 h 1102519"/>
+                <a:gd name="csX6" fmla="*/ 1030664 w 1030664"/>
+                <a:gd name="csY6" fmla="*/ 217912 h 1102519"/>
+                <a:gd name="csX7" fmla="*/ 599657 w 1030664"/>
+                <a:gd name="csY7" fmla="*/ 240803 h 1102519"/>
+                <a:gd name="csX8" fmla="*/ 455235 w 1030664"/>
+                <a:gd name="csY8" fmla="*/ 360787 h 1102519"/>
+                <a:gd name="csX9" fmla="*/ 128587 w 1030664"/>
+                <a:gd name="csY9" fmla="*/ 354806 h 1102519"/>
+                <a:gd name="csX10" fmla="*/ 26194 w 1030664"/>
+                <a:gd name="csY10" fmla="*/ 1102519 h 1102519"/>
+                <a:gd name="csX0" fmla="*/ 26194 w 1030664"/>
+                <a:gd name="csY0" fmla="*/ 1102519 h 1102519"/>
+                <a:gd name="csX1" fmla="*/ 0 w 1030664"/>
+                <a:gd name="csY1" fmla="*/ 135731 h 1102519"/>
+                <a:gd name="csX2" fmla="*/ 116681 w 1030664"/>
+                <a:gd name="csY2" fmla="*/ 14288 h 1102519"/>
+                <a:gd name="csX3" fmla="*/ 397669 w 1030664"/>
+                <a:gd name="csY3" fmla="*/ 0 h 1102519"/>
+                <a:gd name="csX4" fmla="*/ 546853 w 1030664"/>
+                <a:gd name="csY4" fmla="*/ 109242 h 1102519"/>
+                <a:gd name="csX5" fmla="*/ 1023937 w 1030664"/>
+                <a:gd name="csY5" fmla="*/ 71438 h 1102519"/>
+                <a:gd name="csX6" fmla="*/ 1030664 w 1030664"/>
+                <a:gd name="csY6" fmla="*/ 217912 h 1102519"/>
+                <a:gd name="csX7" fmla="*/ 599657 w 1030664"/>
+                <a:gd name="csY7" fmla="*/ 240803 h 1102519"/>
+                <a:gd name="csX8" fmla="*/ 455235 w 1030664"/>
+                <a:gd name="csY8" fmla="*/ 360787 h 1102519"/>
+                <a:gd name="csX9" fmla="*/ 128587 w 1030664"/>
+                <a:gd name="csY9" fmla="*/ 380879 h 1102519"/>
+                <a:gd name="csX10" fmla="*/ 26194 w 1030664"/>
+                <a:gd name="csY10" fmla="*/ 1102519 h 1102519"/>
+              </a:gdLst>
+              <a:ahLst/>
+              <a:cxnLst>
+                <a:cxn ang="0">
+                  <a:pos x="csX0" y="csY0"/>
+                </a:cxn>
+                <a:cxn ang="0">
+                  <a:pos x="csX1" y="csY1"/>
+                </a:cxn>
+                <a:cxn ang="0">
+                  <a:pos x="csX2" y="csY2"/>
+                </a:cxn>
+                <a:cxn ang="0">
+                  <a:pos x="csX3" y="csY3"/>
+                </a:cxn>
+                <a:cxn ang="0">
+                  <a:pos x="csX4" y="csY4"/>
+                </a:cxn>
+                <a:cxn ang="0">
+                  <a:pos x="csX5" y="csY5"/>
+                </a:cxn>
+                <a:cxn ang="0">
+                  <a:pos x="csX6" y="csY6"/>
+                </a:cxn>
+                <a:cxn ang="0">
+                  <a:pos x="csX7" y="csY7"/>
+                </a:cxn>
+                <a:cxn ang="0">
+                  <a:pos x="csX8" y="csY8"/>
+                </a:cxn>
+                <a:cxn ang="0">
+                  <a:pos x="csX9" y="csY9"/>
+                </a:cxn>
+                <a:cxn ang="0">
+                  <a:pos x="csX10" y="csY10"/>
+                </a:cxn>
+              </a:cxnLst>
+              <a:rect l="l" t="t" r="r" b="b"/>
+              <a:pathLst>
+                <a:path w="1030664" h="1102519">
+                  <a:moveTo>
+                    <a:pt x="26194" y="1102519"/>
+                  </a:moveTo>
+                  <a:lnTo>
+                    <a:pt x="0" y="135731"/>
+                  </a:lnTo>
+                  <a:lnTo>
+                    <a:pt x="116681" y="14288"/>
+                  </a:lnTo>
+                  <a:lnTo>
+                    <a:pt x="397669" y="0"/>
+                  </a:lnTo>
+                  <a:lnTo>
+                    <a:pt x="546853" y="109242"/>
+                  </a:lnTo>
+                  <a:lnTo>
+                    <a:pt x="1023937" y="71438"/>
+                  </a:lnTo>
+                  <a:lnTo>
+                    <a:pt x="1030664" y="217912"/>
+                  </a:lnTo>
+                  <a:lnTo>
+                    <a:pt x="599657" y="240803"/>
+                  </a:lnTo>
+                  <a:lnTo>
+                    <a:pt x="455235" y="360787"/>
+                  </a:lnTo>
+                  <a:lnTo>
+                    <a:pt x="128587" y="380879"/>
+                  </a:lnTo>
+                  <a:lnTo>
+                    <a:pt x="26194" y="1102519"/>
+                  </a:lnTo>
+                  <a:close/>
+                </a:path>
+              </a:pathLst>
+            </a:custGeom>
+            <a:solidFill>
+              <a:srgbClr val="FFCF37"/>
+            </a:solidFill>
+            <a:ln w="63500">
+              <a:solidFill>
+                <a:schemeClr val="accent4">
+                  <a:lumMod val="75000"/>
+                </a:schemeClr>
+              </a:solidFill>
+            </a:ln>
+          </p:spPr>
+          <p:style>
+            <a:lnRef idx="2">
+              <a:schemeClr val="accent4">
+                <a:shade val="15000"/>
+              </a:schemeClr>
+            </a:lnRef>
+            <a:fillRef idx="1">
+              <a:schemeClr val="accent4"/>
+            </a:fillRef>
+            <a:effectRef idx="0">
+              <a:schemeClr val="accent4"/>
+            </a:effectRef>
+            <a:fontRef idx="minor">
+              <a:schemeClr val="lt1"/>
+            </a:fontRef>
+          </p:style>
+          <p:txBody>
+            <a:bodyPr rtlCol="0" anchor="ctr"/>
+            <a:lstStyle/>
+            <a:p>
+              <a:pPr algn="ctr"/>
+              <a:endParaRPr lang="en-CA" dirty="0"/>
+            </a:p>
+          </p:txBody>
+        </p:sp>
+        <p:sp>
+          <p:nvSpPr>
+            <p:cNvPr id="6" name="Forme libre : forme 5">
+              <a:extLst>
+                <a:ext uri="{FF2B5EF4-FFF2-40B4-BE49-F238E27FC236}">
+                  <a16:creationId xmlns:a16="http://schemas.microsoft.com/office/drawing/2014/main" id="{FAE5C2F3-1A6D-945D-471A-7CF7CD009B7A}"/>
+                </a:ext>
+              </a:extLst>
+            </p:cNvPr>
+            <p:cNvSpPr/>
+            <p:nvPr/>
+          </p:nvSpPr>
+          <p:spPr>
+            <a:xfrm>
+              <a:off x="5353050" y="2972809"/>
+              <a:ext cx="1132305" cy="887991"/>
+            </a:xfrm>
+            <a:custGeom>
+              <a:avLst/>
+              <a:gdLst>
+                <a:gd name="csX0" fmla="*/ 0 w 1136650"/>
+                <a:gd name="csY0" fmla="*/ 927100 h 927100"/>
+                <a:gd name="csX1" fmla="*/ 95250 w 1136650"/>
+                <a:gd name="csY1" fmla="*/ 184150 h 927100"/>
+                <a:gd name="csX2" fmla="*/ 431800 w 1136650"/>
+                <a:gd name="csY2" fmla="*/ 152400 h 927100"/>
+                <a:gd name="csX3" fmla="*/ 565150 w 1136650"/>
+                <a:gd name="csY3" fmla="*/ 44450 h 927100"/>
+                <a:gd name="csX4" fmla="*/ 1136650 w 1136650"/>
+                <a:gd name="csY4" fmla="*/ 0 h 927100"/>
+                <a:gd name="csX5" fmla="*/ 996950 w 1136650"/>
+                <a:gd name="csY5" fmla="*/ 781050 h 927100"/>
+                <a:gd name="csX6" fmla="*/ 0 w 1136650"/>
+                <a:gd name="csY6" fmla="*/ 927100 h 927100"/>
+                <a:gd name="csX0" fmla="*/ 0 w 1132305"/>
+                <a:gd name="csY0" fmla="*/ 887991 h 887991"/>
+                <a:gd name="csX1" fmla="*/ 95250 w 1132305"/>
+                <a:gd name="csY1" fmla="*/ 145041 h 887991"/>
+                <a:gd name="csX2" fmla="*/ 431800 w 1132305"/>
+                <a:gd name="csY2" fmla="*/ 113291 h 887991"/>
+                <a:gd name="csX3" fmla="*/ 565150 w 1132305"/>
+                <a:gd name="csY3" fmla="*/ 5341 h 887991"/>
+                <a:gd name="csX4" fmla="*/ 1132305 w 1132305"/>
+                <a:gd name="csY4" fmla="*/ 0 h 887991"/>
+                <a:gd name="csX5" fmla="*/ 996950 w 1132305"/>
+                <a:gd name="csY5" fmla="*/ 741941 h 887991"/>
+                <a:gd name="csX6" fmla="*/ 0 w 1132305"/>
+                <a:gd name="csY6" fmla="*/ 887991 h 887991"/>
+                <a:gd name="csX0" fmla="*/ 0 w 1132305"/>
+                <a:gd name="csY0" fmla="*/ 887991 h 887991"/>
+                <a:gd name="csX1" fmla="*/ 95250 w 1132305"/>
+                <a:gd name="csY1" fmla="*/ 145041 h 887991"/>
+                <a:gd name="csX2" fmla="*/ 431800 w 1132305"/>
+                <a:gd name="csY2" fmla="*/ 113291 h 887991"/>
+                <a:gd name="csX3" fmla="*/ 562978 w 1132305"/>
+                <a:gd name="csY3" fmla="*/ 35760 h 887991"/>
+                <a:gd name="csX4" fmla="*/ 1132305 w 1132305"/>
+                <a:gd name="csY4" fmla="*/ 0 h 887991"/>
+                <a:gd name="csX5" fmla="*/ 996950 w 1132305"/>
+                <a:gd name="csY5" fmla="*/ 741941 h 887991"/>
+                <a:gd name="csX6" fmla="*/ 0 w 1132305"/>
+                <a:gd name="csY6" fmla="*/ 887991 h 887991"/>
+                <a:gd name="csX0" fmla="*/ 0 w 1132305"/>
+                <a:gd name="csY0" fmla="*/ 887991 h 887991"/>
+                <a:gd name="csX1" fmla="*/ 95250 w 1132305"/>
+                <a:gd name="csY1" fmla="*/ 145041 h 887991"/>
+                <a:gd name="csX2" fmla="*/ 433429 w 1132305"/>
+                <a:gd name="csY2" fmla="*/ 124697 h 887991"/>
+                <a:gd name="csX3" fmla="*/ 562978 w 1132305"/>
+                <a:gd name="csY3" fmla="*/ 35760 h 887991"/>
+                <a:gd name="csX4" fmla="*/ 1132305 w 1132305"/>
+                <a:gd name="csY4" fmla="*/ 0 h 887991"/>
+                <a:gd name="csX5" fmla="*/ 996950 w 1132305"/>
+                <a:gd name="csY5" fmla="*/ 741941 h 887991"/>
+                <a:gd name="csX6" fmla="*/ 0 w 1132305"/>
+                <a:gd name="csY6" fmla="*/ 887991 h 887991"/>
+              </a:gdLst>
+              <a:ahLst/>
+              <a:cxnLst>
+                <a:cxn ang="0">
+                  <a:pos x="csX0" y="csY0"/>
+                </a:cxn>
+                <a:cxn ang="0">
+                  <a:pos x="csX1" y="csY1"/>
+                </a:cxn>
+                <a:cxn ang="0">
+                  <a:pos x="csX2" y="csY2"/>
+                </a:cxn>
+                <a:cxn ang="0">
+                  <a:pos x="csX3" y="csY3"/>
+                </a:cxn>
+                <a:cxn ang="0">
+                  <a:pos x="csX4" y="csY4"/>
+                </a:cxn>
+                <a:cxn ang="0">
+                  <a:pos x="csX5" y="csY5"/>
+                </a:cxn>
+                <a:cxn ang="0">
+                  <a:pos x="csX6" y="csY6"/>
+                </a:cxn>
+              </a:cxnLst>
+              <a:rect l="l" t="t" r="r" b="b"/>
+              <a:pathLst>
+                <a:path w="1132305" h="887991">
+                  <a:moveTo>
+                    <a:pt x="0" y="887991"/>
+                  </a:moveTo>
+                  <a:lnTo>
+                    <a:pt x="95250" y="145041"/>
+                  </a:lnTo>
+                  <a:lnTo>
+                    <a:pt x="433429" y="124697"/>
+                  </a:lnTo>
+                  <a:lnTo>
+                    <a:pt x="562978" y="35760"/>
+                  </a:lnTo>
+                  <a:lnTo>
+                    <a:pt x="1132305" y="0"/>
+                  </a:lnTo>
+                  <a:lnTo>
+                    <a:pt x="996950" y="741941"/>
+                  </a:lnTo>
+                  <a:lnTo>
+                    <a:pt x="0" y="887991"/>
+                  </a:lnTo>
+                  <a:close/>
+                </a:path>
+              </a:pathLst>
+            </a:custGeom>
+            <a:solidFill>
+              <a:schemeClr val="accent4">
+                <a:lumMod val="40000"/>
+                <a:lumOff val="60000"/>
+              </a:schemeClr>
+            </a:solidFill>
+            <a:ln w="69850">
+              <a:solidFill>
+                <a:schemeClr val="accent4">
+                  <a:lumMod val="75000"/>
+                </a:schemeClr>
+              </a:solidFill>
+              <a:extLst>
+                <a:ext uri="{C807C97D-BFC1-408E-A445-0C87EB9F89A2}">
+                  <ask:lineSketchStyleProps xmlns:ask="http://schemas.microsoft.com/office/drawing/2018/sketchyshapes" sd="1219033472">
+                    <a:custGeom>
+                      <a:avLst/>
+                      <a:gdLst>
+                        <a:gd name="csX0" fmla="*/ 0 w 1654619"/>
+                        <a:gd name="csY0" fmla="*/ 1297607 h 1297607"/>
+                        <a:gd name="csX1" fmla="*/ 72377 w 1654619"/>
+                        <a:gd name="csY1" fmla="*/ 733063 h 1297607"/>
+                        <a:gd name="csX2" fmla="*/ 139187 w 1654619"/>
+                        <a:gd name="csY2" fmla="*/ 211946 h 1297607"/>
+                        <a:gd name="csX3" fmla="*/ 630982 w 1654619"/>
+                        <a:gd name="csY3" fmla="*/ 165550 h 1297607"/>
+                        <a:gd name="csX4" fmla="*/ 822670 w 1654619"/>
+                        <a:gd name="csY4" fmla="*/ 52255 h 1297607"/>
+                        <a:gd name="csX5" fmla="*/ 1222006 w 1654619"/>
+                        <a:gd name="csY5" fmla="*/ 27173 h 1297607"/>
+                        <a:gd name="csX6" fmla="*/ 1654619 w 1654619"/>
+                        <a:gd name="csY6" fmla="*/ 0 h 1297607"/>
+                        <a:gd name="csX7" fmla="*/ 1551767 w 1654619"/>
+                        <a:gd name="csY7" fmla="*/ 563777 h 1297607"/>
+                        <a:gd name="csX8" fmla="*/ 1456826 w 1654619"/>
+                        <a:gd name="csY8" fmla="*/ 1084186 h 1297607"/>
+                        <a:gd name="csX9" fmla="*/ 971217 w 1654619"/>
+                        <a:gd name="csY9" fmla="*/ 1155326 h 1297607"/>
+                        <a:gd name="csX10" fmla="*/ 485609 w 1654619"/>
+                        <a:gd name="csY10" fmla="*/ 1226467 h 1297607"/>
+                        <a:gd name="csX11" fmla="*/ 0 w 1654619"/>
+                        <a:gd name="csY11" fmla="*/ 1297607 h 1297607"/>
+                      </a:gdLst>
+                      <a:ahLst/>
+                      <a:cxnLst>
+                        <a:cxn ang="0">
+                          <a:pos x="csX0" y="csY0"/>
+                        </a:cxn>
+                        <a:cxn ang="0">
+                          <a:pos x="csX1" y="csY1"/>
+                        </a:cxn>
+                        <a:cxn ang="0">
+                          <a:pos x="csX2" y="csY2"/>
+                        </a:cxn>
+                        <a:cxn ang="0">
+                          <a:pos x="csX3" y="csY3"/>
+                        </a:cxn>
+                        <a:cxn ang="0">
+                          <a:pos x="csX4" y="csY4"/>
+                        </a:cxn>
+                        <a:cxn ang="0">
+                          <a:pos x="csX5" y="csY5"/>
+                        </a:cxn>
+                        <a:cxn ang="0">
+                          <a:pos x="csX6" y="csY6"/>
+                        </a:cxn>
+                        <a:cxn ang="0">
+                          <a:pos x="csX7" y="csY7"/>
+                        </a:cxn>
+                        <a:cxn ang="0">
+                          <a:pos x="csX8" y="csY8"/>
+                        </a:cxn>
+                        <a:cxn ang="0">
+                          <a:pos x="csX9" y="csY9"/>
+                        </a:cxn>
+                        <a:cxn ang="0">
+                          <a:pos x="csX10" y="csY10"/>
+                        </a:cxn>
+                        <a:cxn ang="0">
+                          <a:pos x="csX11" y="csY11"/>
+                        </a:cxn>
+                      </a:cxnLst>
+                      <a:rect l="l" t="t" r="r" b="b"/>
+                      <a:pathLst>
+                        <a:path w="1654619" h="1297607" fill="none" extrusionOk="0">
+                          <a:moveTo>
+                            <a:pt x="0" y="1297607"/>
+                          </a:moveTo>
+                          <a:cubicBezTo>
+                            <a:pt x="5602" y="1155706"/>
+                            <a:pt x="101668" y="954816"/>
+                            <a:pt x="72377" y="733063"/>
+                          </a:cubicBezTo>
+                          <a:cubicBezTo>
+                            <a:pt x="43086" y="511310"/>
+                            <a:pt x="161276" y="406076"/>
+                            <a:pt x="139187" y="211946"/>
+                          </a:cubicBezTo>
+                          <a:cubicBezTo>
+                            <a:pt x="306247" y="179667"/>
+                            <a:pt x="440475" y="211059"/>
+                            <a:pt x="630982" y="165550"/>
+                          </a:cubicBezTo>
+                          <a:cubicBezTo>
+                            <a:pt x="715782" y="107491"/>
+                            <a:pt x="744254" y="110610"/>
+                            <a:pt x="822670" y="52255"/>
+                          </a:cubicBezTo>
+                          <a:cubicBezTo>
+                            <a:pt x="1006857" y="23108"/>
+                            <a:pt x="1036070" y="71690"/>
+                            <a:pt x="1222006" y="27173"/>
+                          </a:cubicBezTo>
+                          <a:cubicBezTo>
+                            <a:pt x="1407942" y="-17344"/>
+                            <a:pt x="1553848" y="57463"/>
+                            <a:pt x="1654619" y="0"/>
+                          </a:cubicBezTo>
+                          <a:cubicBezTo>
+                            <a:pt x="1653992" y="252064"/>
+                            <a:pt x="1572797" y="406842"/>
+                            <a:pt x="1551767" y="563777"/>
+                          </a:cubicBezTo>
+                          <a:cubicBezTo>
+                            <a:pt x="1530737" y="720712"/>
+                            <a:pt x="1494318" y="831711"/>
+                            <a:pt x="1456826" y="1084186"/>
+                          </a:cubicBezTo>
+                          <a:cubicBezTo>
+                            <a:pt x="1296779" y="1124336"/>
+                            <a:pt x="1119171" y="1123775"/>
+                            <a:pt x="971217" y="1155326"/>
+                          </a:cubicBezTo>
+                          <a:cubicBezTo>
+                            <a:pt x="823263" y="1186877"/>
+                            <a:pt x="615451" y="1196856"/>
+                            <a:pt x="485609" y="1226467"/>
+                          </a:cubicBezTo>
+                          <a:cubicBezTo>
+                            <a:pt x="355767" y="1256077"/>
+                            <a:pt x="102512" y="1241430"/>
+                            <a:pt x="0" y="1297607"/>
+                          </a:cubicBezTo>
+                          <a:close/>
+                        </a:path>
+                        <a:path w="1654619" h="1297607" stroke="0" extrusionOk="0">
+                          <a:moveTo>
+                            <a:pt x="0" y="1297607"/>
+                          </a:moveTo>
+                          <a:cubicBezTo>
+                            <a:pt x="-13771" y="1052173"/>
+                            <a:pt x="50588" y="1014082"/>
+                            <a:pt x="68202" y="765633"/>
+                          </a:cubicBezTo>
+                          <a:cubicBezTo>
+                            <a:pt x="85815" y="517184"/>
+                            <a:pt x="113703" y="415483"/>
+                            <a:pt x="139187" y="211946"/>
+                          </a:cubicBezTo>
+                          <a:cubicBezTo>
+                            <a:pt x="247491" y="165253"/>
+                            <a:pt x="498541" y="220952"/>
+                            <a:pt x="630982" y="165550"/>
+                          </a:cubicBezTo>
+                          <a:cubicBezTo>
+                            <a:pt x="707710" y="100337"/>
+                            <a:pt x="758751" y="100894"/>
+                            <a:pt x="822670" y="52255"/>
+                          </a:cubicBezTo>
+                          <a:cubicBezTo>
+                            <a:pt x="1013725" y="30009"/>
+                            <a:pt x="1068628" y="63648"/>
+                            <a:pt x="1230325" y="26650"/>
+                          </a:cubicBezTo>
+                          <a:cubicBezTo>
+                            <a:pt x="1392022" y="-10348"/>
+                            <a:pt x="1498009" y="46742"/>
+                            <a:pt x="1654619" y="0"/>
+                          </a:cubicBezTo>
+                          <a:cubicBezTo>
+                            <a:pt x="1670578" y="264432"/>
+                            <a:pt x="1569474" y="425489"/>
+                            <a:pt x="1551767" y="563777"/>
+                          </a:cubicBezTo>
+                          <a:cubicBezTo>
+                            <a:pt x="1534060" y="702065"/>
+                            <a:pt x="1458783" y="860675"/>
+                            <a:pt x="1456826" y="1084186"/>
+                          </a:cubicBezTo>
+                          <a:cubicBezTo>
+                            <a:pt x="1306143" y="1163186"/>
+                            <a:pt x="1162417" y="1121717"/>
+                            <a:pt x="971217" y="1155326"/>
+                          </a:cubicBezTo>
+                          <a:cubicBezTo>
+                            <a:pt x="780017" y="1188935"/>
+                            <a:pt x="623000" y="1159539"/>
+                            <a:pt x="500177" y="1224332"/>
+                          </a:cubicBezTo>
+                          <a:cubicBezTo>
+                            <a:pt x="377354" y="1289125"/>
+                            <a:pt x="105842" y="1228026"/>
+                            <a:pt x="0" y="1297607"/>
+                          </a:cubicBezTo>
+                          <a:close/>
+                        </a:path>
+                      </a:pathLst>
+                    </a:custGeom>
+                    <ask:type>
+                      <ask:lineSketchNone/>
+                    </ask:type>
+                  </ask:lineSketchStyleProps>
+                </a:ext>
+              </a:extLst>
+            </a:ln>
+          </p:spPr>
+          <p:style>
+            <a:lnRef idx="2">
+              <a:schemeClr val="accent4">
+                <a:shade val="15000"/>
+              </a:schemeClr>
+            </a:lnRef>
+            <a:fillRef idx="1">
+              <a:schemeClr val="accent4"/>
+            </a:fillRef>
+            <a:effectRef idx="0">
+              <a:schemeClr val="accent4"/>
+            </a:effectRef>
+            <a:fontRef idx="minor">
+              <a:schemeClr val="lt1"/>
+            </a:fontRef>
+          </p:style>
+          <p:txBody>
+            <a:bodyPr rtlCol="0" anchor="ctr"/>
+            <a:lstStyle/>
+            <a:p>
+              <a:pPr algn="ctr"/>
+              <a:endParaRPr lang="en-CA"/>
+            </a:p>
+          </p:txBody>
+        </p:sp>
+      </p:grpSp>
+    </p:spTree>
+    <p:extLst>
+      <p:ext uri="{BB962C8B-B14F-4D97-AF65-F5344CB8AC3E}">
+        <p14:creationId xmlns:p14="http://schemas.microsoft.com/office/powerpoint/2010/main" val="2959125613"/>
       </p:ext>
     </p:extLst>
   </p:cSld>

</xml_diff>